<commit_message>
Correct the toolkit claim in the README, the deck and the diagram
All three carried "6 of 6 question classes". That came from section 40 and it
was counting clean terminations, not answers. The measured numbers, from
three runs of the same six questions in section 42, are 18/18 on choosing the
right tool, 18/18 on that tool executing, and 3/18 on producing prose about
the shop.

The README also described the toolkit as running "on native function calling".
It does not: this NIM writes its tool calls as text and a provider shim lifts
them into the protocol. That was the whole subject of pass 52, and the README
was still describing the thing that had been broken.

Both artefacts are regenerated from their generators rather than edited, and
both are checked: the deck has 0 geometry issues, 0 runs under 10pt and its
lowest content at 7.00in of 7.50, with validate.py clean; the diagram
validates its seven pages and 321 shapes as before.

Co-Authored-By: Claude Opus 5 <noreply@anthropic.com>
</commit_message>
<xml_diff>
--- a/docs/architecture-deck.pptx
+++ b/docs/architecture-deck.pptx
@@ -113,37 +113,37 @@
   <p:extLst>
     <p:ext uri="{521415D9-36F7-43E2-AB2F-B90AF26B5E84}">
       <p14:sectionLst xmlns:p14="http://schemas.microsoft.com/office/powerpoint/2010/main">
-        <p14:section name="Overview" id="{b3f48f09-44e5-7a4c-0d10-1c216ca4be99}">
+        <p14:section name="Overview" id="{b0c47147-e2a2-34e3-5f7f-18dbb4b5fc23}">
           <p14:sldIdLst>
             <p14:sldId id="256"/>
           </p14:sldIdLst>
         </p14:section>
-        <p14:section name="Architecture" id="{dd4d777a-b73d-59a9-98dc-2a741ff9f7c4}">
+        <p14:section name="Architecture" id="{5db22196-5980-70fd-3f4f-66f753af741e}">
           <p14:sldIdLst>
             <p14:sldId id="257"/>
           </p14:sldIdLst>
         </p14:section>
-        <p14:section name="Application flow" id="{d0df32d4-3302-eca3-090f-189f7095b03e}">
+        <p14:section name="Application flow" id="{5f9d2555-b3f4-334e-2f61-569f41ff298c}">
           <p14:sldIdLst>
             <p14:sldId id="258"/>
           </p14:sldIdLst>
         </p14:section>
-        <p14:section name="Components" id="{624dd53c-68b7-9c05-b2f3-2122b21d6886}">
+        <p14:section name="Components" id="{fc9c831b-f5cf-bbd2-0aca-84c72019ed8d}">
           <p14:sldIdLst>
             <p14:sldId id="259"/>
           </p14:sldIdLst>
         </p14:section>
-        <p14:section name="Deployment" id="{365aebcc-29e1-cbb0-b751-ae4327bcd1ad}">
+        <p14:section name="Deployment" id="{5fd707d8-c64d-7c40-d66b-45383c85c320}">
           <p14:sldIdLst>
             <p14:sldId id="260"/>
           </p14:sldIdLst>
         </p14:section>
-        <p14:section name="Data model" id="{26cc606b-0962-a890-0a4a-fd7e5a8c24c3}">
+        <p14:section name="Data model" id="{aba7288b-78ee-f5f5-2b1d-bec3c1747ac3}">
           <p14:sldIdLst>
             <p14:sldId id="261"/>
           </p14:sldIdLst>
         </p14:section>
-        <p14:section name="Lifecycle" id="{1aa64589-807e-8b33-d5cb-64f672d4edb3}">
+        <p14:section name="Lifecycle" id="{7750e60c-146d-8370-f562-8014bba70216}">
           <p14:sldIdLst>
             <p14:sldId id="262"/>
           </p14:sldIdLst>
@@ -9463,7 +9463,7 @@
                   <a:srgbClr val="5C6B64"/>
                 </a:solidFill>
               </a:rPr>
-              <a:t>A second front end onto the same ten tools.</a:t>
+              <a:t>A second front end onto the same ten tools; its calls arrive as text.</a:t>
             </a:r>
             <a:endParaRPr lang="en-US" sz="1100" dirty="0"/>
           </a:p>
@@ -9499,7 +9499,7 @@
                   <a:srgbClr val="5C6B64"/>
                 </a:solidFill>
               </a:rPr>
-              <a:t>6 of 6 question classes</a:t>
+              <a:t>tools run 18/18 · answers 3/18</a:t>
             </a:r>
             <a:endParaRPr lang="en-US" sz="1000" dirty="0"/>
           </a:p>

</xml_diff>

<commit_message>
Make the process slide in the deck process-only
The deck slide no longer carries the business figures, the 'what that means for the
business' band or the 'what you get' lines; the five stages and the hosted-Riva note
remain. The cards are resized to fit, the build animation is six seconds, and the video
and the standalone clip render the same slide.
</commit_message>
<xml_diff>
--- a/docs/architecture-deck.pptx
+++ b/docs/architecture-deck.pptx
@@ -116,47 +116,47 @@
   <p:extLst>
     <p:ext uri="{521415D9-36F7-43E2-AB2F-B90AF26B5E84}">
       <p14:sectionLst xmlns:p14="http://schemas.microsoft.com/office/powerpoint/2010/main">
-        <p14:section name="Overview" id="{ce4f8d3b-f637-b165-35c1-d99416ff8b6d}">
+        <p14:section name="Overview" id="{b88167c4-f979-1824-c91b-1f92c2c78184}">
           <p14:sldIdLst>
             <p14:sldId id="256"/>
           </p14:sldIdLst>
         </p14:section>
-        <p14:section name="Process" id="{e7716984-b6db-4f73-565a-789556bb6cf3}">
+        <p14:section name="Process" id="{eac9bf67-4895-1517-137c-e1b032580ec3}">
           <p14:sldIdLst>
             <p14:sldId id="257"/>
           </p14:sldIdLst>
         </p14:section>
-        <p14:section name="Architecture" id="{2d76453c-2fe7-6462-d037-75586cccb236}">
+        <p14:section name="Architecture" id="{174cd3e1-5e0f-567a-c33b-7966dddfb007}">
           <p14:sldIdLst>
             <p14:sldId id="258"/>
           </p14:sldIdLst>
         </p14:section>
-        <p14:section name="Application flow" id="{8cbdcc49-68b6-8e82-21d0-de231fad2181}">
+        <p14:section name="Application flow" id="{8b3ae366-bc67-e64e-1a2c-81611cb267ce}">
           <p14:sldIdLst>
             <p14:sldId id="259"/>
           </p14:sldIdLst>
         </p14:section>
-        <p14:section name="Components" id="{0c39a4b9-cc10-dacd-d520-7be399f4348a}">
+        <p14:section name="Components" id="{86d6f8bd-13bc-565d-ad25-0e8f242423ee}">
           <p14:sldIdLst>
             <p14:sldId id="260"/>
           </p14:sldIdLst>
         </p14:section>
-        <p14:section name="Deployment" id="{a3806c42-0726-ac81-a708-b9f1de98754a}">
+        <p14:section name="Deployment" id="{6dbd43a3-7fe3-08e9-43d4-a6806c69c365}">
           <p14:sldIdLst>
             <p14:sldId id="261"/>
           </p14:sldIdLst>
         </p14:section>
-        <p14:section name="Data model" id="{d1a185e3-5e80-b542-0a90-7ee1bd7b5955}">
+        <p14:section name="Data model" id="{c171e4f2-706c-546b-3716-91f77e0bd799}">
           <p14:sldIdLst>
             <p14:sldId id="262"/>
           </p14:sldIdLst>
         </p14:section>
-        <p14:section name="Lifecycle" id="{c4aaec7d-20cd-3c36-9483-176724fa2b7b}">
+        <p14:section name="Lifecycle" id="{01c25880-b6a7-9854-4ea7-e0ec308eb2a6}">
           <p14:sldIdLst>
             <p14:sldId id="263"/>
           </p14:sldIdLst>
         </p14:section>
-        <p14:section name="Usage" id="{65b20251-6e05-c5ec-5e6d-77207e002b9e}">
+        <p14:section name="Usage" id="{8f8099ed-6e0d-3c01-0cd8-e6af9a6bb78d}">
           <p14:sldIdLst>
             <p14:sldId id="264"/>
             <p14:sldId id="265"/>
@@ -742,7 +742,7 @@
           <a:p>
             <a:r>
               <a:rPr lang="en-US" dirty="0"/>
-              <a:t>Narration (demo scene 2): A technician speaks or types an update. NVIDIA Riva Parakeet transcribes it. A Nemotron model extracts the facts. Python checks every one against the catalogue, folds it into an event log, and derives the state of the repair order. Nothing is guessed, and every answer cites its records. The slide builds itself in about eight seconds on entry; it does not need a click.</a:t>
+              <a:t>Narration (demo scene 2): A technician speaks or types an update. NVIDIA Riva Parakeet transcribes it. A Nemotron model extracts the facts. Python checks every one against the catalogue, folds it into an event log, and derives the state of the repair order. Nothing is guessed, and every answer cites its records. The slide builds itself in about six seconds on entry; it does not need a click.</a:t>
             </a:r>
             <a:endParaRPr lang="en-US" dirty="0"/>
           </a:p>
@@ -3315,8 +3315,8 @@
         </p:nvSpPr>
         <p:spPr>
           <a:xfrm>
-            <a:off x="502920" y="1481328"/>
-            <a:ext cx="2017715" cy="2999232"/>
+            <a:off x="502920" y="2194560"/>
+            <a:ext cx="2017715" cy="2377440"/>
           </a:xfrm>
           <a:prstGeom prst="rect">
             <a:avLst/>
@@ -3340,7 +3340,7 @@
         </p:nvSpPr>
         <p:spPr>
           <a:xfrm>
-            <a:off x="630936" y="1234440"/>
+            <a:off x="630936" y="1947672"/>
             <a:ext cx="493776" cy="493776"/>
           </a:xfrm>
           <a:prstGeom prst="ellipse">
@@ -3382,8 +3382,8 @@
         </p:nvSpPr>
         <p:spPr>
           <a:xfrm>
-            <a:off x="630936" y="1810512"/>
-            <a:ext cx="1761683" cy="2066544"/>
+            <a:off x="630936" y="2523744"/>
+            <a:ext cx="1761683" cy="1444752"/>
           </a:xfrm>
           <a:prstGeom prst="rect">
             <a:avLst/>
@@ -3425,7 +3425,7 @@
               <a:buNone/>
             </a:pPr>
             <a:r>
-              <a:rPr lang="en-US" sz="1100" dirty="0">
+              <a:rPr lang="en-US" sz="1200" dirty="0">
                 <a:solidFill>
                   <a:srgbClr val="5C6B64"/>
                 </a:solidFill>
@@ -3434,43 +3434,6 @@
             </a:r>
             <a:endParaRPr lang="en-US" sz="1600" dirty="0"/>
           </a:p>
-          <a:p>
-            <a:pPr indent="0" marL="0">
-              <a:lnSpc>
-                <a:spcPct val="95000"/>
-              </a:lnSpc>
-              <a:spcBef>
-                <a:spcPts val="1000"/>
-              </a:spcBef>
-              <a:buNone/>
-            </a:pPr>
-            <a:r>
-              <a:rPr lang="en-US" sz="1000" b="1" dirty="0">
-                <a:solidFill>
-                  <a:srgbClr val="5B8C3A"/>
-                </a:solidFill>
-              </a:rPr>
-              <a:t>WHAT YOU GET</a:t>
-            </a:r>
-            <a:endParaRPr lang="en-US" sz="1600" dirty="0"/>
-          </a:p>
-          <a:p>
-            <a:pPr indent="0" marL="0">
-              <a:lnSpc>
-                <a:spcPct val="95000"/>
-              </a:lnSpc>
-              <a:buNone/>
-            </a:pPr>
-            <a:r>
-              <a:rPr lang="en-US" sz="1100" dirty="0">
-                <a:solidFill>
-                  <a:srgbClr val="14302A"/>
-                </a:solidFill>
-              </a:rPr>
-              <a:t>No forms. No end-of-shift retyping.</a:t>
-            </a:r>
-            <a:endParaRPr lang="en-US" sz="1600" dirty="0"/>
-          </a:p>
         </p:txBody>
       </p:sp>
       <p:sp>
@@ -3481,7 +3444,7 @@
         </p:nvSpPr>
         <p:spPr>
           <a:xfrm>
-            <a:off x="594360" y="3913632"/>
+            <a:off x="594360" y="4005072"/>
             <a:ext cx="1834835" cy="475488"/>
           </a:xfrm>
           <a:prstGeom prst="rect">
@@ -3543,7 +3506,7 @@
         </p:nvSpPr>
         <p:spPr>
           <a:xfrm>
-            <a:off x="2557211" y="1645920"/>
+            <a:off x="2557211" y="2359152"/>
             <a:ext cx="201168" cy="237744"/>
           </a:xfrm>
           <a:prstGeom prst="rightArrow">
@@ -3568,8 +3531,8 @@
         </p:nvSpPr>
         <p:spPr>
           <a:xfrm>
-            <a:off x="2794955" y="1481328"/>
-            <a:ext cx="2017715" cy="2999232"/>
+            <a:off x="2794955" y="2194560"/>
+            <a:ext cx="2017715" cy="2377440"/>
           </a:xfrm>
           <a:prstGeom prst="rect">
             <a:avLst/>
@@ -3593,7 +3556,7 @@
         </p:nvSpPr>
         <p:spPr>
           <a:xfrm>
-            <a:off x="2922971" y="1234440"/>
+            <a:off x="2922971" y="1947672"/>
             <a:ext cx="493776" cy="493776"/>
           </a:xfrm>
           <a:prstGeom prst="ellipse">
@@ -3635,8 +3598,8 @@
         </p:nvSpPr>
         <p:spPr>
           <a:xfrm>
-            <a:off x="2922971" y="1810512"/>
-            <a:ext cx="1761683" cy="2066544"/>
+            <a:off x="2922971" y="2523744"/>
+            <a:ext cx="1761683" cy="1444752"/>
           </a:xfrm>
           <a:prstGeom prst="rect">
             <a:avLst/>
@@ -3678,7 +3641,7 @@
               <a:buNone/>
             </a:pPr>
             <a:r>
-              <a:rPr lang="en-US" sz="1100" dirty="0">
+              <a:rPr lang="en-US" sz="1200" dirty="0">
                 <a:solidFill>
                   <a:srgbClr val="5C6B64"/>
                 </a:solidFill>
@@ -3687,43 +3650,6 @@
             </a:r>
             <a:endParaRPr lang="en-US" sz="1600" dirty="0"/>
           </a:p>
-          <a:p>
-            <a:pPr indent="0" marL="0">
-              <a:lnSpc>
-                <a:spcPct val="95000"/>
-              </a:lnSpc>
-              <a:spcBef>
-                <a:spcPts val="1000"/>
-              </a:spcBef>
-              <a:buNone/>
-            </a:pPr>
-            <a:r>
-              <a:rPr lang="en-US" sz="1000" b="1" dirty="0">
-                <a:solidFill>
-                  <a:srgbClr val="5B8C3A"/>
-                </a:solidFill>
-              </a:rPr>
-              <a:t>WHAT YOU GET</a:t>
-            </a:r>
-            <a:endParaRPr lang="en-US" sz="1600" dirty="0"/>
-          </a:p>
-          <a:p>
-            <a:pPr indent="0" marL="0">
-              <a:lnSpc>
-                <a:spcPct val="95000"/>
-              </a:lnSpc>
-              <a:buNone/>
-            </a:pPr>
-            <a:r>
-              <a:rPr lang="en-US" sz="1100" dirty="0">
-                <a:solidFill>
-                  <a:srgbClr val="14302A"/>
-                </a:solidFill>
-              </a:rPr>
-              <a:t>Hours, parts and measurements pulled out automatically.</a:t>
-            </a:r>
-            <a:endParaRPr lang="en-US" sz="1600" dirty="0"/>
-          </a:p>
         </p:txBody>
       </p:sp>
       <p:sp>
@@ -3734,7 +3660,7 @@
         </p:nvSpPr>
         <p:spPr>
           <a:xfrm>
-            <a:off x="2886395" y="3913632"/>
+            <a:off x="2886395" y="4005072"/>
             <a:ext cx="1834835" cy="475488"/>
           </a:xfrm>
           <a:prstGeom prst="rect">
@@ -3796,7 +3722,7 @@
         </p:nvSpPr>
         <p:spPr>
           <a:xfrm>
-            <a:off x="4849246" y="1645920"/>
+            <a:off x="4849246" y="2359152"/>
             <a:ext cx="201168" cy="237744"/>
           </a:xfrm>
           <a:prstGeom prst="rightArrow">
@@ -3821,8 +3747,8 @@
         </p:nvSpPr>
         <p:spPr>
           <a:xfrm>
-            <a:off x="5086990" y="1481328"/>
-            <a:ext cx="2017715" cy="2999232"/>
+            <a:off x="5086990" y="2194560"/>
+            <a:ext cx="2017715" cy="2377440"/>
           </a:xfrm>
           <a:prstGeom prst="rect">
             <a:avLst/>
@@ -3846,7 +3772,7 @@
         </p:nvSpPr>
         <p:spPr>
           <a:xfrm>
-            <a:off x="5215006" y="1234440"/>
+            <a:off x="5215006" y="1947672"/>
             <a:ext cx="493776" cy="493776"/>
           </a:xfrm>
           <a:prstGeom prst="ellipse">
@@ -3888,8 +3814,8 @@
         </p:nvSpPr>
         <p:spPr>
           <a:xfrm>
-            <a:off x="5215006" y="1810512"/>
-            <a:ext cx="1761683" cy="2066544"/>
+            <a:off x="5215006" y="2523744"/>
+            <a:ext cx="1761683" cy="1444752"/>
           </a:xfrm>
           <a:prstGeom prst="rect">
             <a:avLst/>
@@ -3931,7 +3857,7 @@
               <a:buNone/>
             </a:pPr>
             <a:r>
-              <a:rPr lang="en-US" sz="1100" dirty="0">
+              <a:rPr lang="en-US" sz="1200" dirty="0">
                 <a:solidFill>
                   <a:srgbClr val="5C6B64"/>
                 </a:solidFill>
@@ -3940,43 +3866,6 @@
             </a:r>
             <a:endParaRPr lang="en-US" sz="1600" dirty="0"/>
           </a:p>
-          <a:p>
-            <a:pPr indent="0" marL="0">
-              <a:lnSpc>
-                <a:spcPct val="95000"/>
-              </a:lnSpc>
-              <a:spcBef>
-                <a:spcPts val="1000"/>
-              </a:spcBef>
-              <a:buNone/>
-            </a:pPr>
-            <a:r>
-              <a:rPr lang="en-US" sz="1000" b="1" dirty="0">
-                <a:solidFill>
-                  <a:srgbClr val="5B8C3A"/>
-                </a:solidFill>
-              </a:rPr>
-              <a:t>WHAT YOU GET</a:t>
-            </a:r>
-            <a:endParaRPr lang="en-US" sz="1600" dirty="0"/>
-          </a:p>
-          <a:p>
-            <a:pPr indent="0" marL="0">
-              <a:lnSpc>
-                <a:spcPct val="95000"/>
-              </a:lnSpc>
-              <a:buNone/>
-            </a:pPr>
-            <a:r>
-              <a:rPr lang="en-US" sz="1100" dirty="0">
-                <a:solidFill>
-                  <a:srgbClr val="14302A"/>
-                </a:solidFill>
-              </a:rPr>
-              <a:t>Nothing is guessed. An unclear update asks a question.</a:t>
-            </a:r>
-            <a:endParaRPr lang="en-US" sz="1600" dirty="0"/>
-          </a:p>
         </p:txBody>
       </p:sp>
       <p:sp>
@@ -3987,7 +3876,7 @@
         </p:nvSpPr>
         <p:spPr>
           <a:xfrm>
-            <a:off x="5178430" y="3913632"/>
+            <a:off x="5178430" y="4005072"/>
             <a:ext cx="1834835" cy="475488"/>
           </a:xfrm>
           <a:prstGeom prst="rect">
@@ -4049,7 +3938,7 @@
         </p:nvSpPr>
         <p:spPr>
           <a:xfrm>
-            <a:off x="7141281" y="1645920"/>
+            <a:off x="7141281" y="2359152"/>
             <a:ext cx="201168" cy="237744"/>
           </a:xfrm>
           <a:prstGeom prst="rightArrow">
@@ -4074,8 +3963,8 @@
         </p:nvSpPr>
         <p:spPr>
           <a:xfrm>
-            <a:off x="7379025" y="1481328"/>
-            <a:ext cx="2017715" cy="2999232"/>
+            <a:off x="7379025" y="2194560"/>
+            <a:ext cx="2017715" cy="2377440"/>
           </a:xfrm>
           <a:prstGeom prst="rect">
             <a:avLst/>
@@ -4099,7 +3988,7 @@
         </p:nvSpPr>
         <p:spPr>
           <a:xfrm>
-            <a:off x="7507041" y="1234440"/>
+            <a:off x="7507041" y="1947672"/>
             <a:ext cx="493776" cy="493776"/>
           </a:xfrm>
           <a:prstGeom prst="ellipse">
@@ -4141,8 +4030,8 @@
         </p:nvSpPr>
         <p:spPr>
           <a:xfrm>
-            <a:off x="7507041" y="1810512"/>
-            <a:ext cx="1761683" cy="2066544"/>
+            <a:off x="7507041" y="2523744"/>
+            <a:ext cx="1761683" cy="1444752"/>
           </a:xfrm>
           <a:prstGeom prst="rect">
             <a:avLst/>
@@ -4184,7 +4073,7 @@
               <a:buNone/>
             </a:pPr>
             <a:r>
-              <a:rPr lang="en-US" sz="1100" dirty="0">
+              <a:rPr lang="en-US" sz="1200" dirty="0">
                 <a:solidFill>
                   <a:srgbClr val="5C6B64"/>
                 </a:solidFill>
@@ -4193,43 +4082,6 @@
             </a:r>
             <a:endParaRPr lang="en-US" sz="1600" dirty="0"/>
           </a:p>
-          <a:p>
-            <a:pPr indent="0" marL="0">
-              <a:lnSpc>
-                <a:spcPct val="95000"/>
-              </a:lnSpc>
-              <a:spcBef>
-                <a:spcPts val="1000"/>
-              </a:spcBef>
-              <a:buNone/>
-            </a:pPr>
-            <a:r>
-              <a:rPr lang="en-US" sz="1000" b="1" dirty="0">
-                <a:solidFill>
-                  <a:srgbClr val="5B8C3A"/>
-                </a:solidFill>
-              </a:rPr>
-              <a:t>WHAT YOU GET</a:t>
-            </a:r>
-            <a:endParaRPr lang="en-US" sz="1600" dirty="0"/>
-          </a:p>
-          <a:p>
-            <a:pPr indent="0" marL="0">
-              <a:lnSpc>
-                <a:spcPct val="95000"/>
-              </a:lnSpc>
-              <a:buNone/>
-            </a:pPr>
-            <a:r>
-              <a:rPr lang="en-US" sz="1100" dirty="0">
-                <a:solidFill>
-                  <a:srgbClr val="14302A"/>
-                </a:solidFill>
-              </a:rPr>
-              <a:t>A full audit trail, and no stale status.</a:t>
-            </a:r>
-            <a:endParaRPr lang="en-US" sz="1600" dirty="0"/>
-          </a:p>
         </p:txBody>
       </p:sp>
       <p:sp>
@@ -4240,7 +4092,7 @@
         </p:nvSpPr>
         <p:spPr>
           <a:xfrm>
-            <a:off x="7470465" y="3913632"/>
+            <a:off x="7470465" y="4005072"/>
             <a:ext cx="1834835" cy="475488"/>
           </a:xfrm>
           <a:prstGeom prst="rect">
@@ -4302,7 +4154,7 @@
         </p:nvSpPr>
         <p:spPr>
           <a:xfrm>
-            <a:off x="9433316" y="1645920"/>
+            <a:off x="9433316" y="2359152"/>
             <a:ext cx="201168" cy="237744"/>
           </a:xfrm>
           <a:prstGeom prst="rightArrow">
@@ -4327,8 +4179,8 @@
         </p:nvSpPr>
         <p:spPr>
           <a:xfrm>
-            <a:off x="9671060" y="1481328"/>
-            <a:ext cx="2017715" cy="2999232"/>
+            <a:off x="9671060" y="2194560"/>
+            <a:ext cx="2017715" cy="2377440"/>
           </a:xfrm>
           <a:prstGeom prst="rect">
             <a:avLst/>
@@ -4352,7 +4204,7 @@
         </p:nvSpPr>
         <p:spPr>
           <a:xfrm>
-            <a:off x="9799076" y="1234440"/>
+            <a:off x="9799076" y="1947672"/>
             <a:ext cx="493776" cy="493776"/>
           </a:xfrm>
           <a:prstGeom prst="ellipse">
@@ -4394,8 +4246,8 @@
         </p:nvSpPr>
         <p:spPr>
           <a:xfrm>
-            <a:off x="9799076" y="1810512"/>
-            <a:ext cx="1761683" cy="2066544"/>
+            <a:off x="9799076" y="2523744"/>
+            <a:ext cx="1761683" cy="1444752"/>
           </a:xfrm>
           <a:prstGeom prst="rect">
             <a:avLst/>
@@ -4437,7 +4289,7 @@
               <a:buNone/>
             </a:pPr>
             <a:r>
-              <a:rPr lang="en-US" sz="1100" dirty="0">
+              <a:rPr lang="en-US" sz="1200" dirty="0">
                 <a:solidFill>
                   <a:srgbClr val="5C6B64"/>
                 </a:solidFill>
@@ -4446,510 +4298,103 @@
             </a:r>
             <a:endParaRPr lang="en-US" sz="1600" dirty="0"/>
           </a:p>
+        </p:txBody>
+      </p:sp>
+      <p:sp>
+        <p:nvSpPr>
+          <p:cNvPr id="27" name="anim-s4-badge"/>
+          <p:cNvSpPr txBox="1"/>
+          <p:nvPr/>
+        </p:nvSpPr>
+        <p:spPr>
+          <a:xfrm>
+            <a:off x="9762500" y="4005072"/>
+            <a:ext cx="1834835" cy="475488"/>
+          </a:xfrm>
+          <a:prstGeom prst="rect">
+            <a:avLst/>
+          </a:prstGeom>
+          <a:solidFill>
+            <a:srgbClr val="5B8C3A"/>
+          </a:solidFill>
+          <a:ln w="12700">
+            <a:solidFill>
+              <a:srgbClr val="446B29"/>
+            </a:solidFill>
+          </a:ln>
+        </p:spPr>
+        <p:txBody>
+          <a:bodyPr wrap="square" lIns="0" tIns="0" rIns="0" bIns="0" rtlCol="0" anchor="ctr"/>
+          <a:lstStyle/>
+          <a:p>
+            <a:pPr algn="ctr" indent="0" marL="0">
+              <a:lnSpc>
+                <a:spcPct val="90000"/>
+              </a:lnSpc>
+              <a:buNone/>
+            </a:pPr>
+            <a:r>
+              <a:rPr lang="en-US" sz="1000" b="1" dirty="0">
+                <a:solidFill>
+                  <a:srgbClr val="FFFFFF"/>
+                </a:solidFill>
+              </a:rPr>
+              <a:t>NVIDIA NIM retrieval</a:t>
+            </a:r>
+            <a:endParaRPr lang="en-US" sz="1000" dirty="0"/>
+          </a:p>
+          <a:p>
+            <a:pPr algn="ctr" indent="0" marL="0">
+              <a:lnSpc>
+                <a:spcPct val="90000"/>
+              </a:lnSpc>
+              <a:buNone/>
+            </a:pPr>
+            <a:r>
+              <a:rPr lang="en-US" sz="1000" b="1" dirty="0">
+                <a:solidFill>
+                  <a:srgbClr val="FFFFFF"/>
+                </a:solidFill>
+              </a:rPr>
+              <a:t>NeMo Guardrails</a:t>
+            </a:r>
+            <a:endParaRPr lang="en-US" sz="1000" dirty="0"/>
+          </a:p>
+        </p:txBody>
+      </p:sp>
+      <p:sp>
+        <p:nvSpPr>
+          <p:cNvPr id="28" name="Text 26"/>
+          <p:cNvSpPr txBox="1"/>
+          <p:nvPr/>
+        </p:nvSpPr>
+        <p:spPr>
+          <a:xfrm>
+            <a:off x="502920" y="5120640"/>
+            <a:ext cx="11185855" cy="237744"/>
+          </a:xfrm>
+          <a:prstGeom prst="rect">
+            <a:avLst/>
+          </a:prstGeom>
+          <a:noFill/>
+          <a:ln/>
+        </p:spPr>
+        <p:txBody>
+          <a:bodyPr wrap="square" lIns="0" tIns="0" rIns="0" bIns="0" rtlCol="0" anchor="ctr"/>
+          <a:lstStyle/>
           <a:p>
             <a:pPr indent="0" marL="0">
-              <a:lnSpc>
-                <a:spcPct val="95000"/>
-              </a:lnSpc>
-              <a:spcBef>
-                <a:spcPts val="1000"/>
-              </a:spcBef>
-              <a:buNone/>
-            </a:pPr>
-            <a:r>
-              <a:rPr lang="en-US" sz="1000" b="1" dirty="0">
-                <a:solidFill>
-                  <a:srgbClr val="5B8C3A"/>
-                </a:solidFill>
-              </a:rPr>
-              <a:t>WHAT YOU GET</a:t>
-            </a:r>
-            <a:endParaRPr lang="en-US" sz="1600" dirty="0"/>
-          </a:p>
-          <a:p>
-            <a:pPr indent="0" marL="0">
-              <a:lnSpc>
-                <a:spcPct val="95000"/>
-              </a:lnSpc>
-              <a:buNone/>
-            </a:pPr>
-            <a:r>
-              <a:rPr lang="en-US" sz="1100" dirty="0">
-                <a:solidFill>
-                  <a:srgbClr val="14302A"/>
-                </a:solidFill>
-              </a:rPr>
-              <a:t>Structured questions answered in about a tenth of a second.</a:t>
-            </a:r>
-            <a:endParaRPr lang="en-US" sz="1600" dirty="0"/>
-          </a:p>
-        </p:txBody>
-      </p:sp>
-      <p:sp>
-        <p:nvSpPr>
-          <p:cNvPr id="27" name="anim-s4-badge"/>
-          <p:cNvSpPr txBox="1"/>
-          <p:nvPr/>
-        </p:nvSpPr>
-        <p:spPr>
-          <a:xfrm>
-            <a:off x="9762500" y="3913632"/>
-            <a:ext cx="1834835" cy="475488"/>
-          </a:xfrm>
-          <a:prstGeom prst="rect">
-            <a:avLst/>
-          </a:prstGeom>
-          <a:solidFill>
-            <a:srgbClr val="5B8C3A"/>
-          </a:solidFill>
-          <a:ln w="12700">
-            <a:solidFill>
-              <a:srgbClr val="446B29"/>
-            </a:solidFill>
-          </a:ln>
-        </p:spPr>
-        <p:txBody>
-          <a:bodyPr wrap="square" lIns="0" tIns="0" rIns="0" bIns="0" rtlCol="0" anchor="ctr"/>
-          <a:lstStyle/>
-          <a:p>
-            <a:pPr algn="ctr" indent="0" marL="0">
-              <a:lnSpc>
-                <a:spcPct val="90000"/>
-              </a:lnSpc>
-              <a:buNone/>
-            </a:pPr>
-            <a:r>
-              <a:rPr lang="en-US" sz="1000" b="1" dirty="0">
-                <a:solidFill>
-                  <a:srgbClr val="FFFFFF"/>
-                </a:solidFill>
-              </a:rPr>
-              <a:t>NVIDIA NIM retrieval</a:t>
-            </a:r>
-            <a:endParaRPr lang="en-US" sz="1000" dirty="0"/>
-          </a:p>
-          <a:p>
-            <a:pPr algn="ctr" indent="0" marL="0">
-              <a:lnSpc>
-                <a:spcPct val="90000"/>
-              </a:lnSpc>
-              <a:buNone/>
-            </a:pPr>
-            <a:r>
-              <a:rPr lang="en-US" sz="1000" b="1" dirty="0">
-                <a:solidFill>
-                  <a:srgbClr val="FFFFFF"/>
-                </a:solidFill>
-              </a:rPr>
-              <a:t>NeMo Guardrails</a:t>
-            </a:r>
-            <a:endParaRPr lang="en-US" sz="1000" dirty="0"/>
-          </a:p>
-        </p:txBody>
-      </p:sp>
-      <p:sp>
-        <p:nvSpPr>
-          <p:cNvPr id="28" name="Shape 26"/>
-          <p:cNvSpPr/>
-          <p:nvPr/>
-        </p:nvSpPr>
-        <p:spPr>
-          <a:xfrm>
-            <a:off x="502920" y="4828032"/>
-            <a:ext cx="11185855" cy="237744"/>
-          </a:xfrm>
-          <a:prstGeom prst="rect">
-            <a:avLst/>
-          </a:prstGeom>
-          <a:solidFill>
-            <a:srgbClr val="14302A"/>
-          </a:solidFill>
-          <a:ln w="12700">
-            <a:solidFill>
-              <a:srgbClr val="14302A"/>
-            </a:solidFill>
-            <a:prstDash val="solid"/>
-          </a:ln>
-        </p:spPr>
-      </p:sp>
-      <p:sp>
-        <p:nvSpPr>
-          <p:cNvPr id="29" name="Text 27"/>
-          <p:cNvSpPr txBox="1"/>
-          <p:nvPr/>
-        </p:nvSpPr>
-        <p:spPr>
-          <a:xfrm>
-            <a:off x="612648" y="4828032"/>
-            <a:ext cx="10966399" cy="237744"/>
-          </a:xfrm>
-          <a:prstGeom prst="rect">
-            <a:avLst/>
-          </a:prstGeom>
-          <a:noFill/>
-          <a:ln/>
-        </p:spPr>
-        <p:txBody>
-          <a:bodyPr wrap="square" lIns="0" tIns="0" rIns="0" bIns="0" rtlCol="0" anchor="ctr"/>
-          <a:lstStyle/>
-          <a:p>
-            <a:pPr algn="l" indent="0" marL="0">
-              <a:buNone/>
-            </a:pPr>
-            <a:r>
-              <a:rPr lang="en-US" sz="1050" b="1" spc="60" kern="0" dirty="0">
-                <a:solidFill>
-                  <a:srgbClr val="FFFFFF"/>
-                </a:solidFill>
-              </a:rPr>
-              <a:t>WHAT THAT MEANS FOR THE BUSINESS</a:t>
-            </a:r>
-            <a:endParaRPr lang="en-US" sz="1050" dirty="0"/>
-          </a:p>
-        </p:txBody>
-      </p:sp>
-      <p:sp>
-        <p:nvSpPr>
-          <p:cNvPr id="30" name="anim-o0-card"/>
-          <p:cNvSpPr/>
-          <p:nvPr/>
-        </p:nvSpPr>
-        <p:spPr>
-          <a:xfrm>
-            <a:off x="502920" y="5138928"/>
-            <a:ext cx="3606698" cy="914400"/>
-          </a:xfrm>
-          <a:prstGeom prst="rect">
-            <a:avLst/>
-          </a:prstGeom>
-          <a:solidFill>
-            <a:srgbClr val="1E4035"/>
-          </a:solidFill>
-          <a:ln w="12700">
-            <a:solidFill>
-              <a:srgbClr val="2E5245"/>
-            </a:solidFill>
-            <a:prstDash val="solid"/>
-          </a:ln>
-        </p:spPr>
-      </p:sp>
-      <p:sp>
-        <p:nvSpPr>
-          <p:cNvPr id="31" name="anim-o0-big"/>
-          <p:cNvSpPr txBox="1"/>
-          <p:nvPr/>
-        </p:nvSpPr>
-        <p:spPr>
-          <a:xfrm>
-            <a:off x="649224" y="5193792"/>
-            <a:ext cx="3332378" cy="420624"/>
-          </a:xfrm>
-          <a:prstGeom prst="rect">
-            <a:avLst/>
-          </a:prstGeom>
-          <a:noFill/>
-          <a:ln/>
-        </p:spPr>
-        <p:txBody>
-          <a:bodyPr wrap="square" lIns="0" tIns="0" rIns="0" bIns="0" rtlCol="0" anchor="ctr"/>
-          <a:lstStyle/>
-          <a:p>
-            <a:pPr indent="0" marL="0">
-              <a:buNone/>
-            </a:pPr>
-            <a:r>
-              <a:rPr lang="en-US" sz="2600" b="1" dirty="0">
-                <a:solidFill>
-                  <a:srgbClr val="76B900"/>
-                </a:solidFill>
-                <a:latin typeface="Arial" pitchFamily="34" charset="0"/>
-                <a:ea typeface="Arial" pitchFamily="34" charset="-122"/>
-                <a:cs typeface="Arial" pitchFamily="34" charset="-120"/>
-              </a:rPr>
-              <a:t>~0.1 s</a:t>
-            </a:r>
-            <a:endParaRPr lang="en-US" sz="2600" dirty="0"/>
-          </a:p>
-        </p:txBody>
-      </p:sp>
-      <p:sp>
-        <p:nvSpPr>
-          <p:cNvPr id="32" name="anim-o0-cap"/>
-          <p:cNvSpPr txBox="1"/>
-          <p:nvPr/>
-        </p:nvSpPr>
-        <p:spPr>
-          <a:xfrm>
-            <a:off x="649224" y="5632704"/>
-            <a:ext cx="3332378" cy="384048"/>
-          </a:xfrm>
-          <a:prstGeom prst="rect">
-            <a:avLst/>
-          </a:prstGeom>
-          <a:noFill/>
-          <a:ln/>
-        </p:spPr>
-        <p:txBody>
-          <a:bodyPr wrap="square" lIns="0" tIns="0" rIns="0" bIns="0" rtlCol="0" anchor="t"/>
-          <a:lstStyle/>
-          <a:p>
-            <a:pPr indent="0" marL="0">
-              <a:lnSpc>
-                <a:spcPct val="95000"/>
-              </a:lnSpc>
-              <a:buNone/>
-            </a:pPr>
-            <a:r>
-              <a:rPr lang="en-US" sz="1100" dirty="0">
-                <a:solidFill>
-                  <a:srgbClr val="DCE8CF"/>
-                </a:solidFill>
-              </a:rPr>
-              <a:t>for a structured answer - computed, no model call</a:t>
+              <a:buNone/>
+            </a:pPr>
+            <a:r>
+              <a:rPr lang="en-US" sz="1100" i="1" dirty="0">
+                <a:solidFill>
+                  <a:srgbClr val="5C6B64"/>
+                </a:solidFill>
+              </a:rPr>
+              <a:t>Speech recognition runs on NVIDIA-hosted Riva; every other model runs on the L40S in the box.</a:t>
             </a:r>
             <a:endParaRPr lang="en-US" sz="1100" dirty="0"/>
-          </a:p>
-        </p:txBody>
-      </p:sp>
-      <p:sp>
-        <p:nvSpPr>
-          <p:cNvPr id="33" name="anim-o1-card"/>
-          <p:cNvSpPr/>
-          <p:nvPr/>
-        </p:nvSpPr>
-        <p:spPr>
-          <a:xfrm>
-            <a:off x="4292498" y="5138928"/>
-            <a:ext cx="3606698" cy="914400"/>
-          </a:xfrm>
-          <a:prstGeom prst="rect">
-            <a:avLst/>
-          </a:prstGeom>
-          <a:solidFill>
-            <a:srgbClr val="1E4035"/>
-          </a:solidFill>
-          <a:ln w="12700">
-            <a:solidFill>
-              <a:srgbClr val="2E5245"/>
-            </a:solidFill>
-            <a:prstDash val="solid"/>
-          </a:ln>
-        </p:spPr>
-      </p:sp>
-      <p:sp>
-        <p:nvSpPr>
-          <p:cNvPr id="34" name="anim-o1-big"/>
-          <p:cNvSpPr txBox="1"/>
-          <p:nvPr/>
-        </p:nvSpPr>
-        <p:spPr>
-          <a:xfrm>
-            <a:off x="4438802" y="5193792"/>
-            <a:ext cx="3332378" cy="420624"/>
-          </a:xfrm>
-          <a:prstGeom prst="rect">
-            <a:avLst/>
-          </a:prstGeom>
-          <a:noFill/>
-          <a:ln/>
-        </p:spPr>
-        <p:txBody>
-          <a:bodyPr wrap="square" lIns="0" tIns="0" rIns="0" bIns="0" rtlCol="0" anchor="ctr"/>
-          <a:lstStyle/>
-          <a:p>
-            <a:pPr indent="0" marL="0">
-              <a:buNone/>
-            </a:pPr>
-            <a:r>
-              <a:rPr lang="en-US" sz="2600" b="1" dirty="0">
-                <a:solidFill>
-                  <a:srgbClr val="76B900"/>
-                </a:solidFill>
-                <a:latin typeface="Arial" pitchFamily="34" charset="0"/>
-                <a:ea typeface="Arial" pitchFamily="34" charset="-122"/>
-                <a:cs typeface="Arial" pitchFamily="34" charset="-120"/>
-              </a:rPr>
-              <a:t>905 / 905</a:t>
-            </a:r>
-            <a:endParaRPr lang="en-US" sz="2600" dirty="0"/>
-          </a:p>
-        </p:txBody>
-      </p:sp>
-      <p:sp>
-        <p:nvSpPr>
-          <p:cNvPr id="35" name="anim-o1-cap"/>
-          <p:cNvSpPr txBox="1"/>
-          <p:nvPr/>
-        </p:nvSpPr>
-        <p:spPr>
-          <a:xfrm>
-            <a:off x="4438802" y="5632704"/>
-            <a:ext cx="3332378" cy="384048"/>
-          </a:xfrm>
-          <a:prstGeom prst="rect">
-            <a:avLst/>
-          </a:prstGeom>
-          <a:noFill/>
-          <a:ln/>
-        </p:spPr>
-        <p:txBody>
-          <a:bodyPr wrap="square" lIns="0" tIns="0" rIns="0" bIns="0" rtlCol="0" anchor="t"/>
-          <a:lstStyle/>
-          <a:p>
-            <a:pPr indent="0" marL="0">
-              <a:lnSpc>
-                <a:spcPct val="95000"/>
-              </a:lnSpc>
-              <a:buNone/>
-            </a:pPr>
-            <a:r>
-              <a:rPr lang="en-US" sz="1100" dirty="0">
-                <a:solidFill>
-                  <a:srgbClr val="DCE8CF"/>
-                </a:solidFill>
-              </a:rPr>
-              <a:t>answer citations resolve to a real record, in our evaluation set</a:t>
-            </a:r>
-            <a:endParaRPr lang="en-US" sz="1100" dirty="0"/>
-          </a:p>
-        </p:txBody>
-      </p:sp>
-      <p:sp>
-        <p:nvSpPr>
-          <p:cNvPr id="36" name="anim-o2-card"/>
-          <p:cNvSpPr/>
-          <p:nvPr/>
-        </p:nvSpPr>
-        <p:spPr>
-          <a:xfrm>
-            <a:off x="8082077" y="5138928"/>
-            <a:ext cx="3606698" cy="914400"/>
-          </a:xfrm>
-          <a:prstGeom prst="rect">
-            <a:avLst/>
-          </a:prstGeom>
-          <a:solidFill>
-            <a:srgbClr val="1E4035"/>
-          </a:solidFill>
-          <a:ln w="12700">
-            <a:solidFill>
-              <a:srgbClr val="2E5245"/>
-            </a:solidFill>
-            <a:prstDash val="solid"/>
-          </a:ln>
-        </p:spPr>
-      </p:sp>
-      <p:sp>
-        <p:nvSpPr>
-          <p:cNvPr id="37" name="anim-o2-big"/>
-          <p:cNvSpPr txBox="1"/>
-          <p:nvPr/>
-        </p:nvSpPr>
-        <p:spPr>
-          <a:xfrm>
-            <a:off x="8228381" y="5193792"/>
-            <a:ext cx="3332378" cy="420624"/>
-          </a:xfrm>
-          <a:prstGeom prst="rect">
-            <a:avLst/>
-          </a:prstGeom>
-          <a:noFill/>
-          <a:ln/>
-        </p:spPr>
-        <p:txBody>
-          <a:bodyPr wrap="square" lIns="0" tIns="0" rIns="0" bIns="0" rtlCol="0" anchor="ctr"/>
-          <a:lstStyle/>
-          <a:p>
-            <a:pPr indent="0" marL="0">
-              <a:buNone/>
-            </a:pPr>
-            <a:r>
-              <a:rPr lang="en-US" sz="2600" b="1" dirty="0">
-                <a:solidFill>
-                  <a:srgbClr val="76B900"/>
-                </a:solidFill>
-                <a:latin typeface="Arial" pitchFamily="34" charset="0"/>
-                <a:ea typeface="Arial" pitchFamily="34" charset="-122"/>
-                <a:cs typeface="Arial" pitchFamily="34" charset="-120"/>
-              </a:rPr>
-              <a:t>1.8 &lt; 3.0 mm</a:t>
-            </a:r>
-            <a:endParaRPr lang="en-US" sz="2600" dirty="0"/>
-          </a:p>
-        </p:txBody>
-      </p:sp>
-      <p:sp>
-        <p:nvSpPr>
-          <p:cNvPr id="38" name="anim-o2-cap"/>
-          <p:cNvSpPr txBox="1"/>
-          <p:nvPr/>
-        </p:nvSpPr>
-        <p:spPr>
-          <a:xfrm>
-            <a:off x="8228381" y="5632704"/>
-            <a:ext cx="3332378" cy="384048"/>
-          </a:xfrm>
-          <a:prstGeom prst="rect">
-            <a:avLst/>
-          </a:prstGeom>
-          <a:noFill/>
-          <a:ln/>
-        </p:spPr>
-        <p:txBody>
-          <a:bodyPr wrap="square" lIns="0" tIns="0" rIns="0" bIns="0" rtlCol="0" anchor="t"/>
-          <a:lstStyle/>
-          <a:p>
-            <a:pPr indent="0" marL="0">
-              <a:lnSpc>
-                <a:spcPct val="95000"/>
-              </a:lnSpc>
-              <a:buNone/>
-            </a:pPr>
-            <a:r>
-              <a:rPr lang="en-US" sz="1100" dirty="0">
-                <a:solidFill>
-                  <a:srgbClr val="DCE8CF"/>
-                </a:solidFill>
-              </a:rPr>
-              <a:t>an out-of-spec measurement flags the vehicle unsafe to release, automatically</a:t>
-            </a:r>
-            <a:endParaRPr lang="en-US" sz="1100" dirty="0"/>
-          </a:p>
-        </p:txBody>
-      </p:sp>
-      <p:sp>
-        <p:nvSpPr>
-          <p:cNvPr id="39" name="Text 37"/>
-          <p:cNvSpPr txBox="1"/>
-          <p:nvPr/>
-        </p:nvSpPr>
-        <p:spPr>
-          <a:xfrm>
-            <a:off x="502920" y="6236208"/>
-            <a:ext cx="11185855" cy="237744"/>
-          </a:xfrm>
-          <a:prstGeom prst="rect">
-            <a:avLst/>
-          </a:prstGeom>
-          <a:noFill/>
-          <a:ln/>
-        </p:spPr>
-        <p:txBody>
-          <a:bodyPr wrap="square" lIns="0" tIns="0" rIns="0" bIns="0" rtlCol="0" anchor="ctr"/>
-          <a:lstStyle/>
-          <a:p>
-            <a:pPr indent="0" marL="0">
-              <a:buNone/>
-            </a:pPr>
-            <a:r>
-              <a:rPr lang="en-US" sz="1000" i="1" dirty="0">
-                <a:solidFill>
-                  <a:srgbClr val="5C6B64"/>
-                </a:solidFill>
-              </a:rPr>
-              <a:t>Speech recognition runs on NVIDIA-hosted Riva; every other model runs on the L40S in the box.</a:t>
-            </a:r>
-            <a:endParaRPr lang="en-US" sz="1000" dirty="0"/>
           </a:p>
         </p:txBody>
       </p:sp>
@@ -4976,7 +4421,7 @@
                       </p:stCondLst>
                       <p:childTnLst>
                         <p:par>
-                          <p:cTn id="103" fill="hold">
+                          <p:cTn id="76" fill="hold">
                             <p:stCondLst>
                               <p:cond delay="0"/>
                             </p:stCondLst>
@@ -5821,321 +5266,6 @@
                                   </p:childTnLst>
                                 </p:cTn>
                               </p:par>
-                              <p:par>
-                                <p:cTn id="76" presetID="10" presetClass="entr" presetSubtype="0" fill="hold" nodeType="withEffect">
-                                  <p:stCondLst>
-                                    <p:cond delay="6700"/>
-                                  </p:stCondLst>
-                                  <p:childTnLst>
-                                    <p:set>
-                                      <p:cBhvr>
-                                        <p:cTn id="77" dur="1" fill="hold">
-                                          <p:stCondLst>
-                                            <p:cond delay="0"/>
-                                          </p:stCondLst>
-                                        </p:cTn>
-                                        <p:tgtEl>
-                                          <p:spTgt spid="30"/>
-                                        </p:tgtEl>
-                                        <p:attrNameLst>
-                                          <p:attrName>style.visibility</p:attrName>
-                                        </p:attrNameLst>
-                                      </p:cBhvr>
-                                      <p:to>
-                                        <p:strVal val="visible"/>
-                                      </p:to>
-                                    </p:set>
-                                    <p:animEffect transition="in" filter="fade">
-                                      <p:cBhvr>
-                                        <p:cTn id="78" dur="500"/>
-                                        <p:tgtEl>
-                                          <p:spTgt spid="30"/>
-                                        </p:tgtEl>
-                                      </p:cBhvr>
-                                    </p:animEffect>
-                                  </p:childTnLst>
-                                </p:cTn>
-                              </p:par>
-                              <p:par>
-                                <p:cTn id="79" presetID="10" presetClass="entr" presetSubtype="0" fill="hold" nodeType="withEffect">
-                                  <p:stCondLst>
-                                    <p:cond delay="6700"/>
-                                  </p:stCondLst>
-                                  <p:childTnLst>
-                                    <p:set>
-                                      <p:cBhvr>
-                                        <p:cTn id="80" dur="1" fill="hold">
-                                          <p:stCondLst>
-                                            <p:cond delay="0"/>
-                                          </p:stCondLst>
-                                        </p:cTn>
-                                        <p:tgtEl>
-                                          <p:spTgt spid="31"/>
-                                        </p:tgtEl>
-                                        <p:attrNameLst>
-                                          <p:attrName>style.visibility</p:attrName>
-                                        </p:attrNameLst>
-                                      </p:cBhvr>
-                                      <p:to>
-                                        <p:strVal val="visible"/>
-                                      </p:to>
-                                    </p:set>
-                                    <p:animEffect transition="in" filter="fade">
-                                      <p:cBhvr>
-                                        <p:cTn id="81" dur="500"/>
-                                        <p:tgtEl>
-                                          <p:spTgt spid="31"/>
-                                        </p:tgtEl>
-                                      </p:cBhvr>
-                                    </p:animEffect>
-                                  </p:childTnLst>
-                                </p:cTn>
-                              </p:par>
-                              <p:par>
-                                <p:cTn id="82" presetID="10" presetClass="entr" presetSubtype="0" fill="hold" nodeType="withEffect">
-                                  <p:stCondLst>
-                                    <p:cond delay="6700"/>
-                                  </p:stCondLst>
-                                  <p:childTnLst>
-                                    <p:set>
-                                      <p:cBhvr>
-                                        <p:cTn id="83" dur="1" fill="hold">
-                                          <p:stCondLst>
-                                            <p:cond delay="0"/>
-                                          </p:stCondLst>
-                                        </p:cTn>
-                                        <p:tgtEl>
-                                          <p:spTgt spid="32"/>
-                                        </p:tgtEl>
-                                        <p:attrNameLst>
-                                          <p:attrName>style.visibility</p:attrName>
-                                        </p:attrNameLst>
-                                      </p:cBhvr>
-                                      <p:to>
-                                        <p:strVal val="visible"/>
-                                      </p:to>
-                                    </p:set>
-                                    <p:animEffect transition="in" filter="fade">
-                                      <p:cBhvr>
-                                        <p:cTn id="84" dur="500"/>
-                                        <p:tgtEl>
-                                          <p:spTgt spid="32"/>
-                                        </p:tgtEl>
-                                      </p:cBhvr>
-                                    </p:animEffect>
-                                  </p:childTnLst>
-                                </p:cTn>
-                              </p:par>
-                              <p:par>
-                                <p:cTn id="85" presetID="10" presetClass="entr" presetSubtype="0" fill="hold" nodeType="withEffect">
-                                  <p:stCondLst>
-                                    <p:cond delay="7150"/>
-                                  </p:stCondLst>
-                                  <p:childTnLst>
-                                    <p:set>
-                                      <p:cBhvr>
-                                        <p:cTn id="86" dur="1" fill="hold">
-                                          <p:stCondLst>
-                                            <p:cond delay="0"/>
-                                          </p:stCondLst>
-                                        </p:cTn>
-                                        <p:tgtEl>
-                                          <p:spTgt spid="33"/>
-                                        </p:tgtEl>
-                                        <p:attrNameLst>
-                                          <p:attrName>style.visibility</p:attrName>
-                                        </p:attrNameLst>
-                                      </p:cBhvr>
-                                      <p:to>
-                                        <p:strVal val="visible"/>
-                                      </p:to>
-                                    </p:set>
-                                    <p:animEffect transition="in" filter="fade">
-                                      <p:cBhvr>
-                                        <p:cTn id="87" dur="500"/>
-                                        <p:tgtEl>
-                                          <p:spTgt spid="33"/>
-                                        </p:tgtEl>
-                                      </p:cBhvr>
-                                    </p:animEffect>
-                                  </p:childTnLst>
-                                </p:cTn>
-                              </p:par>
-                              <p:par>
-                                <p:cTn id="88" presetID="10" presetClass="entr" presetSubtype="0" fill="hold" nodeType="withEffect">
-                                  <p:stCondLst>
-                                    <p:cond delay="7150"/>
-                                  </p:stCondLst>
-                                  <p:childTnLst>
-                                    <p:set>
-                                      <p:cBhvr>
-                                        <p:cTn id="89" dur="1" fill="hold">
-                                          <p:stCondLst>
-                                            <p:cond delay="0"/>
-                                          </p:stCondLst>
-                                        </p:cTn>
-                                        <p:tgtEl>
-                                          <p:spTgt spid="34"/>
-                                        </p:tgtEl>
-                                        <p:attrNameLst>
-                                          <p:attrName>style.visibility</p:attrName>
-                                        </p:attrNameLst>
-                                      </p:cBhvr>
-                                      <p:to>
-                                        <p:strVal val="visible"/>
-                                      </p:to>
-                                    </p:set>
-                                    <p:animEffect transition="in" filter="fade">
-                                      <p:cBhvr>
-                                        <p:cTn id="90" dur="500"/>
-                                        <p:tgtEl>
-                                          <p:spTgt spid="34"/>
-                                        </p:tgtEl>
-                                      </p:cBhvr>
-                                    </p:animEffect>
-                                  </p:childTnLst>
-                                </p:cTn>
-                              </p:par>
-                              <p:par>
-                                <p:cTn id="91" presetID="10" presetClass="entr" presetSubtype="0" fill="hold" nodeType="withEffect">
-                                  <p:stCondLst>
-                                    <p:cond delay="7150"/>
-                                  </p:stCondLst>
-                                  <p:childTnLst>
-                                    <p:set>
-                                      <p:cBhvr>
-                                        <p:cTn id="92" dur="1" fill="hold">
-                                          <p:stCondLst>
-                                            <p:cond delay="0"/>
-                                          </p:stCondLst>
-                                        </p:cTn>
-                                        <p:tgtEl>
-                                          <p:spTgt spid="35"/>
-                                        </p:tgtEl>
-                                        <p:attrNameLst>
-                                          <p:attrName>style.visibility</p:attrName>
-                                        </p:attrNameLst>
-                                      </p:cBhvr>
-                                      <p:to>
-                                        <p:strVal val="visible"/>
-                                      </p:to>
-                                    </p:set>
-                                    <p:animEffect transition="in" filter="fade">
-                                      <p:cBhvr>
-                                        <p:cTn id="93" dur="500"/>
-                                        <p:tgtEl>
-                                          <p:spTgt spid="35"/>
-                                        </p:tgtEl>
-                                      </p:cBhvr>
-                                    </p:animEffect>
-                                  </p:childTnLst>
-                                </p:cTn>
-                              </p:par>
-                              <p:par>
-                                <p:cTn id="94" presetID="10" presetClass="entr" presetSubtype="0" fill="hold" nodeType="withEffect">
-                                  <p:stCondLst>
-                                    <p:cond delay="7600"/>
-                                  </p:stCondLst>
-                                  <p:childTnLst>
-                                    <p:set>
-                                      <p:cBhvr>
-                                        <p:cTn id="95" dur="1" fill="hold">
-                                          <p:stCondLst>
-                                            <p:cond delay="0"/>
-                                          </p:stCondLst>
-                                        </p:cTn>
-                                        <p:tgtEl>
-                                          <p:spTgt spid="36"/>
-                                        </p:tgtEl>
-                                        <p:attrNameLst>
-                                          <p:attrName>style.visibility</p:attrName>
-                                        </p:attrNameLst>
-                                      </p:cBhvr>
-                                      <p:to>
-                                        <p:strVal val="visible"/>
-                                      </p:to>
-                                    </p:set>
-                                    <p:animEffect transition="in" filter="fade">
-                                      <p:cBhvr>
-                                        <p:cTn id="96" dur="500"/>
-                                        <p:tgtEl>
-                                          <p:spTgt spid="36"/>
-                                        </p:tgtEl>
-                                      </p:cBhvr>
-                                    </p:animEffect>
-                                  </p:childTnLst>
-                                </p:cTn>
-                              </p:par>
-                              <p:par>
-                                <p:cTn id="97" presetID="10" presetClass="entr" presetSubtype="0" fill="hold" nodeType="withEffect">
-                                  <p:stCondLst>
-                                    <p:cond delay="7600"/>
-                                  </p:stCondLst>
-                                  <p:childTnLst>
-                                    <p:set>
-                                      <p:cBhvr>
-                                        <p:cTn id="98" dur="1" fill="hold">
-                                          <p:stCondLst>
-                                            <p:cond delay="0"/>
-                                          </p:stCondLst>
-                                        </p:cTn>
-                                        <p:tgtEl>
-                                          <p:spTgt spid="37"/>
-                                        </p:tgtEl>
-                                        <p:attrNameLst>
-                                          <p:attrName>style.visibility</p:attrName>
-                                        </p:attrNameLst>
-                                      </p:cBhvr>
-                                      <p:to>
-                                        <p:strVal val="visible"/>
-                                      </p:to>
-                                    </p:set>
-                                    <p:animEffect transition="in" filter="fade">
-                                      <p:cBhvr>
-                                        <p:cTn id="99" dur="500"/>
-                                        <p:tgtEl>
-                                          <p:spTgt spid="37"/>
-                                        </p:tgtEl>
-                                      </p:cBhvr>
-                                    </p:animEffect>
-                                  </p:childTnLst>
-                                </p:cTn>
-                              </p:par>
-                              <p:par>
-                                <p:cTn id="100" presetID="10" presetClass="entr" presetSubtype="0" fill="hold" nodeType="withEffect">
-                                  <p:stCondLst>
-                                    <p:cond delay="7600"/>
-                                  </p:stCondLst>
-                                  <p:childTnLst>
-                                    <p:set>
-                                      <p:cBhvr>
-                                        <p:cTn id="101" dur="1" fill="hold">
-                                          <p:stCondLst>
-                                            <p:cond delay="0"/>
-                                          </p:stCondLst>
-                                        </p:cTn>
-                                        <p:tgtEl>
-                                          <p:spTgt spid="38"/>
-                                        </p:tgtEl>
-                                        <p:attrNameLst>
-                                          <p:attrName>style.visibility</p:attrName>
-                                        </p:attrNameLst>
-                                      </p:cBhvr>
-                                      <p:to>
-                                        <p:strVal val="visible"/>
-                                      </p:to>
-                                    </p:set>
-                                    <p:animEffect transition="in" filter="fade">
-                                      <p:cBhvr>
-                                        <p:cTn id="102" dur="500"/>
-                                        <p:tgtEl>
-                                          <p:spTgt spid="38"/>
-                                        </p:tgtEl>
-                                      </p:cBhvr>
-                                    </p:animEffect>
-                                  </p:childTnLst>
-                                </p:cTn>
-                              </p:par>
                             </p:childTnLst>
                           </p:cTn>
                         </p:par>

</xml_diff>